<commit_message>
PS08: replace Bakery with the MCS lock; three algorithms
The group kept the sheet's two required locks and chose the MCS queue
lock as the extra one: it is the well-known lock (Dijkstra Prize 2006)
that Linux's spinlock is built on, and short enough to explain. Bakery
is dropped. Thanaboon presents MCS alongside the method; the comparison
is split between Worawut (throughput) and Chanon (summary table).

The one-CPU claim now asserts "over 10x slower than pthread_mutex"
rather than 100x: MCS on one CPU measured about 87x at two threads,
and the slides never quote the ratio, only the measured rates.

Co-Authored-By: Claude Opus 5.5 <noreply@anthropic.com>
</commit_message>
<xml_diff>
--- a/PS08/slides/PS08.pptx
+++ b/PS08/slides/PS08.pptx
@@ -33,6 +33,7 @@
     <p:sldId id="278" r:id="rId31"/>
     <p:sldId id="279" r:id="rId32"/>
     <p:sldId id="280" r:id="rId33"/>
+    <p:sldId id="281" r:id="rId34"/>
   </p:sldIdLst>
   <p:sldSz cx="12192000" cy="6858000"/>
   <p:notesSz cx="6858000" cy="9144000"/>
@@ -220,10 +221,10 @@
                 <c:formatCode>General</c:formatCode>
                 <c:ptCount val="2"/>
                 <c:pt idx="0">
-                  <c:v>67.920163</c:v>
+                  <c:v>63.452307</c:v>
                 </c:pt>
                 <c:pt idx="1">
-                  <c:v>18.05578</c:v>
+                  <c:v>15.021417</c:v>
                 </c:pt>
               </c:numCache>
             </c:numRef>
@@ -264,10 +265,10 @@
                 <c:formatCode>General</c:formatCode>
                 <c:ptCount val="2"/>
                 <c:pt idx="0">
-                  <c:v>68.207781</c:v>
+                  <c:v>64.294579</c:v>
                 </c:pt>
                 <c:pt idx="1">
-                  <c:v>0.191643</c:v>
+                  <c:v>0.164672</c:v>
                 </c:pt>
               </c:numCache>
             </c:numRef>
@@ -443,16 +444,16 @@
                 <c:formatCode>General</c:formatCode>
                 <c:ptCount val="4"/>
                 <c:pt idx="0">
-                  <c:v>115.001974</c:v>
+                  <c:v>107.301199</c:v>
                 </c:pt>
                 <c:pt idx="1">
-                  <c:v>18.227358</c:v>
+                  <c:v>17.253647</c:v>
                 </c:pt>
                 <c:pt idx="2">
-                  <c:v>8.781207</c:v>
+                  <c:v>8.673039</c:v>
                 </c:pt>
                 <c:pt idx="3">
-                  <c:v>6.382294</c:v>
+                  <c:v>6.147459</c:v>
                 </c:pt>
               </c:numCache>
             </c:numRef>
@@ -500,16 +501,16 @@
                 <c:formatCode>General</c:formatCode>
                 <c:ptCount val="4"/>
                 <c:pt idx="0">
-                  <c:v>114.820807</c:v>
+                  <c:v>108.946595</c:v>
                 </c:pt>
                 <c:pt idx="1">
-                  <c:v>60.079975</c:v>
+                  <c:v>55.604984</c:v>
                 </c:pt>
                 <c:pt idx="2">
-                  <c:v>28.918768</c:v>
+                  <c:v>28.822359</c:v>
                 </c:pt>
                 <c:pt idx="3">
-                  <c:v>14.103501</c:v>
+                  <c:v>14.007492</c:v>
                 </c:pt>
               </c:numCache>
             </c:numRef>
@@ -557,16 +558,16 @@
                 <c:formatCode>General</c:formatCode>
                 <c:ptCount val="4"/>
                 <c:pt idx="0">
-                  <c:v>109.738311</c:v>
+                  <c:v>101.477403</c:v>
                 </c:pt>
                 <c:pt idx="1">
-                  <c:v>23.410838</c:v>
+                  <c:v>23.167569</c:v>
                 </c:pt>
                 <c:pt idx="2">
-                  <c:v>9.574425</c:v>
+                  <c:v>9.528568</c:v>
                 </c:pt>
                 <c:pt idx="3">
-                  <c:v>5.794615</c:v>
+                  <c:v>5.674698</c:v>
                 </c:pt>
               </c:numCache>
             </c:numRef>
@@ -614,16 +615,16 @@
                 <c:formatCode>General</c:formatCode>
                 <c:ptCount val="4"/>
                 <c:pt idx="0">
-                  <c:v>109.840924</c:v>
+                  <c:v>107.731984</c:v>
                 </c:pt>
                 <c:pt idx="1">
-                  <c:v>56.040178</c:v>
+                  <c:v>53.259232</c:v>
                 </c:pt>
                 <c:pt idx="2">
-                  <c:v>28.76698</c:v>
+                  <c:v>27.371293</c:v>
                 </c:pt>
                 <c:pt idx="3">
-                  <c:v>13.962459</c:v>
+                  <c:v>13.652423</c:v>
                 </c:pt>
               </c:numCache>
             </c:numRef>
@@ -753,7 +754,7 @@
               <c:strCache>
                 <c:ptCount val="1"/>
                 <c:pt idx="0">
-                  <c:v>Bakery, all 8 CPUs</c:v>
+                  <c:v>MCS, all 8 CPUs</c:v>
                 </c:pt>
               </c:strCache>
             </c:strRef>
@@ -785,16 +786,16 @@
                 <c:formatCode>General</c:formatCode>
                 <c:ptCount val="4"/>
                 <c:pt idx="0">
-                  <c:v>34.104665</c:v>
+                  <c:v>53.380392</c:v>
                 </c:pt>
                 <c:pt idx="1">
-                  <c:v>8.401917</c:v>
+                  <c:v>14.774002</c:v>
                 </c:pt>
                 <c:pt idx="2">
-                  <c:v>4.809303</c:v>
+                  <c:v>10.203251</c:v>
                 </c:pt>
                 <c:pt idx="3">
-                  <c:v>2.999472</c:v>
+                  <c:v>6.876554</c:v>
                 </c:pt>
               </c:numCache>
             </c:numRef>
@@ -810,7 +811,7 @@
               <c:strCache>
                 <c:ptCount val="1"/>
                 <c:pt idx="0">
-                  <c:v>Bakery, one CPU</c:v>
+                  <c:v>MCS, one CPU</c:v>
                 </c:pt>
               </c:strCache>
             </c:strRef>
@@ -842,16 +843,16 @@
                 <c:formatCode>General</c:formatCode>
                 <c:ptCount val="4"/>
                 <c:pt idx="0">
-                  <c:v>34.453691</c:v>
+                  <c:v>53.122737</c:v>
                 </c:pt>
                 <c:pt idx="1">
-                  <c:v>0.05582</c:v>
+                  <c:v>0.615147</c:v>
                 </c:pt>
                 <c:pt idx="2">
-                  <c:v>0.169242</c:v>
+                  <c:v>0.400297</c:v>
                 </c:pt>
                 <c:pt idx="3">
-                  <c:v>0.090003</c:v>
+                  <c:v>0.511094</c:v>
                 </c:pt>
               </c:numCache>
             </c:numRef>
@@ -867,7 +868,7 @@
               <c:strCache>
                 <c:ptCount val="1"/>
                 <c:pt idx="0">
-                  <c:v>pthread_mutex, all 8 CPUs</c:v>
+                  <c:v>TAS, all 8 CPUs</c:v>
                 </c:pt>
               </c:strCache>
             </c:strRef>
@@ -899,16 +900,73 @@
                 <c:formatCode>General</c:formatCode>
                 <c:ptCount val="4"/>
                 <c:pt idx="0">
-                  <c:v>54.932697</c:v>
+                  <c:v>101.477403</c:v>
                 </c:pt>
                 <c:pt idx="1">
-                  <c:v>15.722737</c:v>
+                  <c:v>23.167569</c:v>
                 </c:pt>
                 <c:pt idx="2">
-                  <c:v>19.072451</c:v>
+                  <c:v>9.528568</c:v>
                 </c:pt>
                 <c:pt idx="3">
-                  <c:v>19.599804</c:v>
+                  <c:v>5.674698</c:v>
+                </c:pt>
+              </c:numCache>
+            </c:numRef>
+          </c:val>
+          <c:smooth val="0"/>
+        </c:ser>
+        <c:ser>
+          <c:idx val="3"/>
+          <c:order val="3"/>
+          <c:tx>
+            <c:strRef>
+              <c:f>Sheet1!$E$1</c:f>
+              <c:strCache>
+                <c:ptCount val="1"/>
+                <c:pt idx="0">
+                  <c:v>TAS, one CPU</c:v>
+                </c:pt>
+              </c:strCache>
+            </c:strRef>
+          </c:tx>
+          <c:cat>
+            <c:strRef>
+              <c:f>Sheet1!$A$2:$A$5</c:f>
+              <c:strCache>
+                <c:ptCount val="4"/>
+                <c:pt idx="0">
+                  <c:v>1</c:v>
+                </c:pt>
+                <c:pt idx="1">
+                  <c:v>2</c:v>
+                </c:pt>
+                <c:pt idx="2">
+                  <c:v>4</c:v>
+                </c:pt>
+                <c:pt idx="3">
+                  <c:v>8</c:v>
+                </c:pt>
+              </c:strCache>
+            </c:strRef>
+          </c:cat>
+          <c:val>
+            <c:numRef>
+              <c:f>Sheet1!$E$2:$E$5</c:f>
+              <c:numCache>
+                <c:formatCode>General</c:formatCode>
+                <c:ptCount val="4"/>
+                <c:pt idx="0">
+                  <c:v>107.731984</c:v>
+                </c:pt>
+                <c:pt idx="1">
+                  <c:v>53.259232</c:v>
+                </c:pt>
+                <c:pt idx="2">
+                  <c:v>27.371293</c:v>
+                </c:pt>
+                <c:pt idx="3">
+                  <c:v>13.652423</c:v>
                 </c:pt>
               </c:numCache>
             </c:numRef>
@@ -957,8 +1015,8 @@
         <c:axId val="2140495176"/>
         <c:scaling>
           <c:logBase val="10"/>
-          <c:max val="100.0"/>
-          <c:min val="0.01"/>
+          <c:max val="1000.0"/>
+          <c:min val="0.1"/>
         </c:scaling>
         <c:delete val="0"/>
         <c:axPos val="l"/>
@@ -1086,10 +1144,10 @@
                 <c:formatCode>General</c:formatCode>
                 <c:ptCount val="4"/>
                 <c:pt idx="0">
-                  <c:v>67.920163</c:v>
+                  <c:v>63.452307</c:v>
                 </c:pt>
                 <c:pt idx="1">
-                  <c:v>18.05578</c:v>
+                  <c:v>15.021417</c:v>
                 </c:pt>
               </c:numCache>
             </c:numRef>
@@ -1137,16 +1195,16 @@
                 <c:formatCode>General</c:formatCode>
                 <c:ptCount val="4"/>
                 <c:pt idx="0">
-                  <c:v>115.001974</c:v>
+                  <c:v>107.301199</c:v>
                 </c:pt>
                 <c:pt idx="1">
-                  <c:v>18.227358</c:v>
+                  <c:v>17.253647</c:v>
                 </c:pt>
                 <c:pt idx="2">
-                  <c:v>8.781207</c:v>
+                  <c:v>8.673039</c:v>
                 </c:pt>
                 <c:pt idx="3">
-                  <c:v>6.382294</c:v>
+                  <c:v>6.147459</c:v>
                 </c:pt>
               </c:numCache>
             </c:numRef>
@@ -1162,7 +1220,7 @@
               <c:strCache>
                 <c:ptCount val="1"/>
                 <c:pt idx="0">
-                  <c:v>Bakery</c:v>
+                  <c:v>MCS</c:v>
                 </c:pt>
               </c:strCache>
             </c:strRef>
@@ -1194,16 +1252,16 @@
                 <c:formatCode>General</c:formatCode>
                 <c:ptCount val="4"/>
                 <c:pt idx="0">
-                  <c:v>34.104665</c:v>
+                  <c:v>53.380392</c:v>
                 </c:pt>
                 <c:pt idx="1">
-                  <c:v>8.401917</c:v>
+                  <c:v>14.774002</c:v>
                 </c:pt>
                 <c:pt idx="2">
-                  <c:v>4.809303</c:v>
+                  <c:v>10.203251</c:v>
                 </c:pt>
                 <c:pt idx="3">
-                  <c:v>2.999472</c:v>
+                  <c:v>6.876554</c:v>
                 </c:pt>
               </c:numCache>
             </c:numRef>
@@ -1251,16 +1309,16 @@
                 <c:formatCode>General</c:formatCode>
                 <c:ptCount val="4"/>
                 <c:pt idx="0">
-                  <c:v>109.738311</c:v>
+                  <c:v>101.477403</c:v>
                 </c:pt>
                 <c:pt idx="1">
-                  <c:v>23.410838</c:v>
+                  <c:v>23.167569</c:v>
                 </c:pt>
                 <c:pt idx="2">
-                  <c:v>9.574425</c:v>
+                  <c:v>9.528568</c:v>
                 </c:pt>
                 <c:pt idx="3">
-                  <c:v>5.794615</c:v>
+                  <c:v>5.674698</c:v>
                 </c:pt>
               </c:numCache>
             </c:numRef>
@@ -1308,16 +1366,16 @@
                 <c:formatCode>General</c:formatCode>
                 <c:ptCount val="4"/>
                 <c:pt idx="0">
-                  <c:v>54.932697</c:v>
+                  <c:v>52.567284</c:v>
                 </c:pt>
                 <c:pt idx="1">
-                  <c:v>15.722737</c:v>
+                  <c:v>15.116433</c:v>
                 </c:pt>
                 <c:pt idx="2">
-                  <c:v>19.072451</c:v>
+                  <c:v>19.356313</c:v>
                 </c:pt>
                 <c:pt idx="3">
-                  <c:v>19.599804</c:v>
+                  <c:v>20.296315</c:v>
                 </c:pt>
               </c:numCache>
             </c:numRef>
@@ -1495,10 +1553,10 @@
                 <c:formatCode>General</c:formatCode>
                 <c:ptCount val="4"/>
                 <c:pt idx="0">
-                  <c:v>68.207781</c:v>
+                  <c:v>64.294579</c:v>
                 </c:pt>
                 <c:pt idx="1">
-                  <c:v>0.191643</c:v>
+                  <c:v>0.164672</c:v>
                 </c:pt>
               </c:numCache>
             </c:numRef>
@@ -1546,16 +1604,16 @@
                 <c:formatCode>General</c:formatCode>
                 <c:ptCount val="4"/>
                 <c:pt idx="0">
-                  <c:v>114.820807</c:v>
+                  <c:v>108.946595</c:v>
                 </c:pt>
                 <c:pt idx="1">
-                  <c:v>60.079975</c:v>
+                  <c:v>55.604984</c:v>
                 </c:pt>
                 <c:pt idx="2">
-                  <c:v>28.918768</c:v>
+                  <c:v>28.822359</c:v>
                 </c:pt>
                 <c:pt idx="3">
-                  <c:v>14.103501</c:v>
+                  <c:v>14.007492</c:v>
                 </c:pt>
               </c:numCache>
             </c:numRef>
@@ -1571,7 +1629,7 @@
               <c:strCache>
                 <c:ptCount val="1"/>
                 <c:pt idx="0">
-                  <c:v>Bakery</c:v>
+                  <c:v>MCS</c:v>
                 </c:pt>
               </c:strCache>
             </c:strRef>
@@ -1603,16 +1661,16 @@
                 <c:formatCode>General</c:formatCode>
                 <c:ptCount val="4"/>
                 <c:pt idx="0">
-                  <c:v>34.453691</c:v>
+                  <c:v>53.122737</c:v>
                 </c:pt>
                 <c:pt idx="1">
-                  <c:v>0.05582</c:v>
+                  <c:v>0.615147</c:v>
                 </c:pt>
                 <c:pt idx="2">
-                  <c:v>0.169242</c:v>
+                  <c:v>0.400297</c:v>
                 </c:pt>
                 <c:pt idx="3">
-                  <c:v>0.090003</c:v>
+                  <c:v>0.511094</c:v>
                 </c:pt>
               </c:numCache>
             </c:numRef>
@@ -1660,16 +1718,16 @@
                 <c:formatCode>General</c:formatCode>
                 <c:ptCount val="4"/>
                 <c:pt idx="0">
-                  <c:v>109.840924</c:v>
+                  <c:v>107.731984</c:v>
                 </c:pt>
                 <c:pt idx="1">
-                  <c:v>56.040178</c:v>
+                  <c:v>53.259232</c:v>
                 </c:pt>
                 <c:pt idx="2">
-                  <c:v>28.76698</c:v>
+                  <c:v>27.371293</c:v>
                 </c:pt>
                 <c:pt idx="3">
-                  <c:v>13.962459</c:v>
+                  <c:v>13.652423</c:v>
                 </c:pt>
               </c:numCache>
             </c:numRef>
@@ -1717,16 +1775,16 @@
                 <c:formatCode>General</c:formatCode>
                 <c:ptCount val="4"/>
                 <c:pt idx="0">
-                  <c:v>53.707997</c:v>
+                  <c:v>52.968008</c:v>
                 </c:pt>
                 <c:pt idx="1">
-                  <c:v>54.947375</c:v>
+                  <c:v>53.803712</c:v>
                 </c:pt>
                 <c:pt idx="2">
-                  <c:v>55.530698</c:v>
+                  <c:v>52.472641</c:v>
                 </c:pt>
                 <c:pt idx="3">
-                  <c:v>56.086632</c:v>
+                  <c:v>54.235798</c:v>
                 </c:pt>
               </c:numCache>
             </c:numRef>
@@ -1776,7 +1834,7 @@
         <c:scaling>
           <c:logBase val="10"/>
           <c:max val="1000.0"/>
-          <c:min val="0.01"/>
+          <c:min val="0.1"/>
         </c:scaling>
         <c:delete val="0"/>
         <c:axPos val="l"/>
@@ -2232,7 +2290,7 @@
           <a:lstStyle/>
           <a:p>
             <a:r>
-              <a:t>We are group OS InW. This deck studies three locks that were not covered in Lecture 8: Peterson's algorithm, Load-Linked/Store-Conditional, and Lamport's bakery algorithm. Each lock is judged on correctness and performance with the metrics from the lecture.</a:t>
+              <a:t>We are group OS InW. This deck studies three locks that were not covered in Lecture 8: Peterson's algorithm, Load-Linked/Store-Conditional, and the MCS queue lock. Each lock is judged on correctness and performance with the metrics from the lecture.</a:t>
             </a:r>
           </a:p>
         </p:txBody>
@@ -2652,7 +2710,7 @@
           <a:lstStyle/>
           <a:p>
             <a:r>
-              <a:t>Part three, the lock not covered in the lecture: Lamport's bakery algorithm.</a:t>
+              <a:t>Part three, the lock not covered in the lecture: the MCS queue lock.</a:t>
             </a:r>
           </a:p>
         </p:txBody>
@@ -2722,7 +2780,7 @@
           <a:lstStyle/>
           <a:p>
             <a:r>
-              <a:t>The bakery algorithm works like taking a number at a bakery counter. Each thread takes one more than the largest number it sees, and the smallest number is served first. Two threads choosing at the same moment can get the same number, so the lower thread id breaks the tie.</a:t>
+              <a:t>The MCS lock, by Mellor-Crummey and Scott, won the Dijkstra Prize in 2006. Waiting threads form a queue, a linked list. Each thread spins on a flag in its own node, and the thread ahead of it clears that flag when it is done. Linux's spinlock today, the qspinlock, is built on this idea.</a:t>
             </a:r>
           </a:p>
         </p:txBody>
@@ -2792,7 +2850,7 @@
           <a:lstStyle/>
           <a:p>
             <a:r>
-              <a:t>The pairs of number and thread id are all different, so they put the waiting threads in one order. A thread only enters once every thread ahead of it has left. All 24 bakery runs finished with nothing lost.</a:t>
+              <a:t>The atomic exchange puts every thread in one queue, and only the head of that queue may enter. A thread leaves by handing the lock to the node behind it, or by resetting tail if nobody is waiting. All 24 runs finished with nothing lost.</a:t>
             </a:r>
           </a:p>
         </p:txBody>
@@ -2862,7 +2920,7 @@
           <a:lstStyle/>
           <a:p>
             <a:r>
-              <a:t>Every acquisition reads every thread's number and choosing flag, so the cost grows with the number of threads, and each entry is a cache line shared with other cores. On one CPU each handoff waits until the next thread in line is scheduled.</a:t>
+              <a:t>Every waiter spins on its own cache line, so a handover touches one line instead of making every core fight over the same flag. On one CPU it collapses: the queue hands the lock to a thread that is not running. The Linux kernel avoids that by disabling preemption while a spinlock is held or awaited.</a:t>
             </a:r>
           </a:p>
         </p:txBody>
@@ -2932,7 +2990,7 @@
           <a:lstStyle/>
           <a:p>
             <a:r>
-              <a:t>Bakery is first-come, first-served, and it was the fairest lock we measured at eight threads. Its costs are linear time and space in the number of threads and ticket numbers that keep growing while threads keep contending.</a:t>
+              <a:t>The queue makes MCS first-come, first-served: it was the fairest lock we measured at eight threads. It needs a node per waiting thread and an atomic exchange, and like every spin lock it suffers when the next thread in line is not running.</a:t>
             </a:r>
           </a:p>
         </p:txBody>
@@ -3002,7 +3060,7 @@
           <a:lstStyle/>
           <a:p>
             <a:r>
-              <a:t>There are six of us. One member explains how we measured, three members each present one lock, one compares them, and one concludes.</a:t>
+              <a:t>There are six of us. Three members each present one lock, and one of them also explains how we measured; two compare the locks and one concludes.</a:t>
             </a:r>
           </a:p>
         </p:txBody>
@@ -3142,7 +3200,7 @@
           <a:lstStyle/>
           <a:p>
             <a:r>
-              <a:t>On all 8 CPUs, pthread_mutex was fastest at eight threads and Bakery slowest. On one CPU the spinning locks waste time slices, while the mutex puts waiting threads to sleep.</a:t>
+              <a:t>On all 8 CPUs, pthread_mutex was the fastest lock at eight threads. On one CPU the spinning locks waste time slices, while the mutex puts waiting threads to sleep.</a:t>
             </a:r>
           </a:p>
         </p:txBody>
@@ -3212,7 +3270,7 @@
           <a:lstStyle/>
           <a:p>
             <a:r>
-              <a:t>This table puts the three locks and the two references on one page, each at the most threads it supports. Fairness and speed pull in opposite directions: the fair software locks are slow, the fast hardware spin locks are unfair.</a:t>
+              <a:t>Next, the same results as one table.</a:t>
             </a:r>
           </a:p>
         </p:txBody>
@@ -3282,7 +3340,7 @@
           <a:lstStyle/>
           <a:p>
             <a:r>
-              <a:t>Last part: what the measurements tell us, and where the material comes from.</a:t>
+              <a:t>This table puts the three locks and the two references on one page, each at the most threads it supports. Peterson is fair but limited to two threads, the simple hardware spin locks are unfair, and the MCS queue is fair at every thread count we ran.</a:t>
             </a:r>
           </a:p>
         </p:txBody>
@@ -3352,7 +3410,7 @@
           <a:lstStyle/>
           <a:p>
             <a:r>
-              <a:t>All three locks provide mutual exclusion and avoid deadlock, but the two software locks only do so on today's CPUs with memory fences. Software locks are fair but slow and limited; the hardware lock is fast but unfair. Real systems combine a hardware atomic with sleeping in the kernel, which is what pthread_mutex does.</a:t>
+              <a:t>Last part: what the measurements tell us, and where the material comes from.</a:t>
             </a:r>
           </a:p>
         </p:txBody>
@@ -3378,6 +3436,76 @@
 </file>
 
 <file path=ppt/notesSlides/notesSlide25.xml><?xml version="1.0" encoding="utf-8"?>
+<p:notes xmlns:a="http://schemas.openxmlformats.org/drawingml/2006/main" xmlns:p="http://schemas.openxmlformats.org/presentationml/2006/main" xmlns:r="http://schemas.openxmlformats.org/officeDocument/2006/relationships">
+  <p:cSld>
+    <p:spTree>
+      <p:nvGrpSpPr>
+        <p:cNvPr id="1" name=""/>
+        <p:cNvGrpSpPr/>
+        <p:nvPr/>
+      </p:nvGrpSpPr>
+      <p:grpSpPr>
+        <a:xfrm>
+          <a:off x="0" y="0"/>
+          <a:ext cx="0" cy="0"/>
+          <a:chOff x="0" y="0"/>
+          <a:chExt cx="0" cy="0"/>
+        </a:xfrm>
+      </p:grpSpPr>
+      <p:sp>
+        <p:nvSpPr>
+          <p:cNvPr id="2" name="Slide Image Placeholder 1"/>
+          <p:cNvSpPr>
+            <a:spLocks noGrp="1"/>
+          </p:cNvSpPr>
+          <p:nvPr>
+            <p:ph type="sldImg" idx="2"/>
+          </p:nvPr>
+        </p:nvSpPr>
+        <p:spPr/>
+      </p:sp>
+      <p:sp>
+        <p:nvSpPr>
+          <p:cNvPr id="3" name="Notes Placeholder 2"/>
+          <p:cNvSpPr>
+            <a:spLocks noGrp="1"/>
+          </p:cNvSpPr>
+          <p:nvPr>
+            <p:ph type="body" idx="3" sz="quarter"/>
+          </p:nvPr>
+        </p:nvSpPr>
+        <p:spPr/>
+        <p:txBody>
+          <a:bodyPr/>
+          <a:lstStyle/>
+          <a:p>
+            <a:r>
+              <a:t>All three locks provide mutual exclusion and avoid deadlock, but Peterson only does so on today's CPUs with a memory fence. Peterson is fair but limited to two threads; LL/SC is short and fast but unfair; the MCS queue is fair for any number of threads and is what Linux builds its spinlock on. When threads can be preempted, sleeping locks such as pthread_mutex win.</a:t>
+            </a:r>
+          </a:p>
+        </p:txBody>
+      </p:sp>
+      <p:sp>
+        <p:nvSpPr>
+          <p:cNvPr id="4" name="Slide Number Placeholder 3"/>
+          <p:cNvSpPr>
+            <a:spLocks noGrp="1"/>
+          </p:cNvSpPr>
+          <p:nvPr>
+            <p:ph type="sldNum" idx="5" sz="quarter"/>
+          </p:nvPr>
+        </p:nvSpPr>
+        <p:spPr/>
+      </p:sp>
+    </p:spTree>
+  </p:cSld>
+  <p:clrMapOvr>
+    <a:masterClrMapping/>
+  </p:clrMapOvr>
+</p:notes>
+</file>
+
+<file path=ppt/notesSlides/notesSlide26.xml><?xml version="1.0" encoding="utf-8"?>
 <p:notes xmlns:a="http://schemas.openxmlformats.org/drawingml/2006/main" xmlns:p="http://schemas.openxmlformats.org/presentationml/2006/main" xmlns:r="http://schemas.openxmlformats.org/officeDocument/2006/relationships">
   <p:cSld>
     <p:spTree>
@@ -6803,7 +6931,7 @@
           <a:lstStyle/>
           <a:p>
             <a:r>
-              <a:t>Peterson's Algorithm · LL/SC · Lamport's Bakery</a:t>
+              <a:t>Peterson's Algorithm · LL/SC · MCS Lock</a:t>
             </a:r>
           </a:p>
           <a:p>
@@ -7589,7 +7717,7 @@
             </a:pPr>
             <a:r>
               <a:rPr sz="1900"/>
-              <a:t>• AArch64 build under qemu-aarch64 10.2.1, 4 threads: lost = 0 in 3 / 3 runs (5,520,491+ acquisitions each)</a:t>
+              <a:t>• AArch64 build under qemu-aarch64 10.2.1, 4 threads: lost = 0 in 3 / 3 runs (5,252,862+ acquisitions each)</a:t>
             </a:r>
           </a:p>
         </p:txBody>
@@ -7935,7 +8063,7 @@
             </a:pPr>
             <a:r>
               <a:rPr sz="1800"/>
-              <a:t>• All CPUs: 115 M acq/s with 1 thread → 6.4 M with 8 — every try pulls the flag's cache line</a:t>
+              <a:t>• All CPUs: 107 M acq/s with 1 thread → 6.1 M with 8 — every try pulls the flag's cache line</a:t>
             </a:r>
           </a:p>
           <a:p>
@@ -8064,7 +8192,7 @@
             </a:pPr>
             <a:r>
               <a:rPr sz="2000"/>
-              <a:t>• No queue: the first SC to land wins — fairness at 8 threads 0.45 (all CPUs), 0.00 (one CPU; run 1: the unluckiest thread got 1 of 14,215,110)</a:t>
+              <a:t>• No queue: the first SC to land wins — fairness at 8 threads 0.75 (all CPUs), 0.00 (one CPU; run 1: the unluckiest thread got 1 of 14,638,997)</a:t>
             </a:r>
           </a:p>
           <a:p>
@@ -8169,7 +8297,7 @@
           <a:lstStyle/>
           <a:p>
             <a:r>
-              <a:t>Lamport's Bakery Algorithm</a:t>
+              <a:t>MCS Lock</a:t>
             </a:r>
           </a:p>
         </p:txBody>
@@ -8190,12 +8318,12 @@
           <a:lstStyle/>
           <a:p>
             <a:r>
-              <a:t>67070501040</a:t>
-            </a:r>
-          </a:p>
-          <a:p>
-            <a:r>
-              <a:t>Worawut Sereethai</a:t>
+              <a:t>67070501021</a:t>
+            </a:r>
+          </a:p>
+          <a:p>
+            <a:r>
+              <a:t>Thanaboon Tikaew</a:t>
             </a:r>
           </a:p>
         </p:txBody>
@@ -8268,7 +8396,7 @@
           <a:lstStyle/>
           <a:p>
             <a:r>
-              <a:t>Bakery Algorithm: Idea</a:t>
+              <a:t>MCS Lock: Idea</a:t>
             </a:r>
           </a:p>
         </p:txBody>
@@ -8335,8 +8463,8 @@
               </a:spcAft>
             </a:pPr>
             <a:r>
-              <a:rPr sz="2000"/>
-              <a:t>• Take a number: 1 + the largest number in use</a:t>
+              <a:rPr sz="1800"/>
+              <a:t>• Mellor-Crummey and Scott, 1991; Dijkstra Prize 2006</a:t>
             </a:r>
           </a:p>
           <a:p>
@@ -8346,8 +8474,8 @@
               </a:spcAft>
             </a:pPr>
             <a:r>
-              <a:rPr sz="2000"/>
-              <a:t>• Smallest number enters first; equal numbers → lower thread id first</a:t>
+              <a:rPr sz="1800"/>
+              <a:t>• Waiters form a queue: a linked list of nodes, tail points to the last</a:t>
             </a:r>
           </a:p>
           <a:p>
@@ -8357,8 +8485,8 @@
               </a:spcAft>
             </a:pPr>
             <a:r>
-              <a:rPr sz="2000"/>
-              <a:t>• choosing[j]: wait until j has finished picking</a:t>
+              <a:rPr sz="1800"/>
+              <a:t>• Join: one atomic exchange on tail, then link in behind the previous node</a:t>
             </a:r>
           </a:p>
           <a:p>
@@ -8368,8 +8496,23 @@
               </a:spcAft>
             </a:pPr>
             <a:r>
-              <a:rPr sz="2000"/>
-              <a:t>• N threads, only loads and stores (Lamport, 1974)</a:t>
+              <a:rPr sz="1800"/>
+              <a:t>• Each thread spins on its OWN node; the one ahead clears it on release</a:t>
+            </a:r>
+          </a:p>
+          <a:p>
+            <a:pPr>
+              <a:spcAft>
+                <a:spcPts val="800"/>
+              </a:spcAft>
+            </a:pPr>
+            <a:r>
+              <a:rPr sz="1800">
+                <a:solidFill>
+                  <a:srgbClr val="C0392B"/>
+                </a:solidFill>
+              </a:rPr>
+              <a:t>• Linux's spinlock (qspinlock, since v4.2) is built on MCS</a:t>
             </a:r>
           </a:p>
         </p:txBody>
@@ -8383,7 +8526,7 @@
         <p:spPr>
           <a:xfrm>
             <a:off x="5120640" y="1463040"/>
-            <a:ext cx="6675120" cy="4914900"/>
+            <a:ext cx="6675120" cy="3291840"/>
           </a:xfrm>
           <a:prstGeom prst="rect">
             <a:avLst/>
@@ -8404,10 +8547,10 @@
               </a:spcAft>
             </a:pPr>
             <a:r>
-              <a:rPr sz="1150">
+              <a:rPr sz="1200">
                 <a:latin typeface="Consolas"/>
               </a:rPr>
-              <a:t>void lock_acquire(int i)</a:t>
+              <a:t>struct node {</a:t>
             </a:r>
           </a:p>
           <a:p>
@@ -8417,7 +8560,66 @@
               </a:spcAft>
             </a:pPr>
             <a:r>
-              <a:rPr sz="1150">
+              <a:rPr sz="1200">
+                <a:latin typeface="Consolas"/>
+              </a:rPr>
+              <a:t>    struct node *next;          /* the thread queued behind me */</a:t>
+            </a:r>
+          </a:p>
+          <a:p>
+            <a:pPr>
+              <a:spcAft>
+                <a:spcPts val="0"/>
+              </a:spcAft>
+            </a:pPr>
+            <a:r>
+              <a:rPr sz="1200">
+                <a:latin typeface="Consolas"/>
+              </a:rPr>
+              <a:t>    int locked;                 /* 1 = keep waiting */</a:t>
+            </a:r>
+          </a:p>
+          <a:p>
+            <a:pPr>
+              <a:spcAft>
+                <a:spcPts val="0"/>
+              </a:spcAft>
+            </a:pPr>
+            <a:r>
+              <a:rPr sz="1200">
+                <a:latin typeface="Consolas"/>
+              </a:rPr>
+              <a:t>} __attribute__((aligned(64)));  /* one cache line per node */</a:t>
+            </a:r>
+          </a:p>
+          <a:p>
+            <a:pPr>
+              <a:spcAft>
+                <a:spcPts val="0"/>
+              </a:spcAft>
+            </a:pPr>
+          </a:p>
+          <a:p>
+            <a:pPr>
+              <a:spcAft>
+                <a:spcPts val="0"/>
+              </a:spcAft>
+            </a:pPr>
+            <a:r>
+              <a:rPr sz="1200">
+                <a:latin typeface="Consolas"/>
+              </a:rPr>
+              <a:t>void lock_acquire(int id)</a:t>
+            </a:r>
+          </a:p>
+          <a:p>
+            <a:pPr>
+              <a:spcAft>
+                <a:spcPts val="0"/>
+              </a:spcAft>
+            </a:pPr>
+            <a:r>
+              <a:rPr sz="1200">
                 <a:latin typeface="Consolas"/>
               </a:rPr>
               <a:t>{</a:t>
@@ -8430,10 +8632,10 @@
               </a:spcAft>
             </a:pPr>
             <a:r>
-              <a:rPr sz="1150">
+              <a:rPr sz="1200">
                 <a:latin typeface="Consolas"/>
               </a:rPr>
-              <a:t>    choosing[i] = 1;</a:t>
+              <a:t>    struct node *me = &amp;qnode[id];</a:t>
             </a:r>
           </a:p>
           <a:p>
@@ -8443,10 +8645,10 @@
               </a:spcAft>
             </a:pPr>
             <a:r>
-              <a:rPr sz="1150">
+              <a:rPr sz="1200">
                 <a:latin typeface="Consolas"/>
               </a:rPr>
-              <a:t>    FENCE();</a:t>
+              <a:t>    me-&gt;next = NULL;</a:t>
             </a:r>
           </a:p>
           <a:p>
@@ -8456,10 +8658,10 @@
               </a:spcAft>
             </a:pPr>
             <a:r>
-              <a:rPr sz="1150">
+              <a:rPr sz="1200">
                 <a:latin typeface="Consolas"/>
               </a:rPr>
-              <a:t>    unsigned max = 0;</a:t>
+              <a:t>    me-&gt;locked = 1;</a:t>
             </a:r>
           </a:p>
           <a:p>
@@ -8469,10 +8671,10 @@
               </a:spcAft>
             </a:pPr>
             <a:r>
-              <a:rPr sz="1150">
+              <a:rPr sz="1200">
                 <a:latin typeface="Consolas"/>
               </a:rPr>
-              <a:t>    for (int j = 0; j &lt; n; j++)</a:t>
+              <a:t>    struct node *prev = __atomic_exchange_n(&amp;tail, me, __ATOMIC_ACQ_REL);</a:t>
             </a:r>
           </a:p>
           <a:p>
@@ -8482,10 +8684,10 @@
               </a:spcAft>
             </a:pPr>
             <a:r>
-              <a:rPr sz="1150">
+              <a:rPr sz="1200">
                 <a:latin typeface="Consolas"/>
               </a:rPr>
-              <a:t>        if (number[j] &gt; max) max = number[j];</a:t>
+              <a:t>    if (prev != NULL) {         /* queue not empty: */</a:t>
             </a:r>
           </a:p>
           <a:p>
@@ -8495,10 +8697,10 @@
               </a:spcAft>
             </a:pPr>
             <a:r>
-              <a:rPr sz="1150">
+              <a:rPr sz="1200">
                 <a:latin typeface="Consolas"/>
               </a:rPr>
-              <a:t>    number[i] = max + 1;        /* take the next number */</a:t>
+              <a:t>        STORE(&amp;prev-&gt;next, me); /* link in behind prev */</a:t>
             </a:r>
           </a:p>
           <a:p>
@@ -8508,10 +8710,10 @@
               </a:spcAft>
             </a:pPr>
             <a:r>
-              <a:rPr sz="1150">
+              <a:rPr sz="1200">
                 <a:latin typeface="Consolas"/>
               </a:rPr>
-              <a:t>    FENCE();</a:t>
+              <a:t>        while (LOAD(&amp;me-&gt;locked))</a:t>
             </a:r>
           </a:p>
           <a:p>
@@ -8521,10 +8723,10 @@
               </a:spcAft>
             </a:pPr>
             <a:r>
-              <a:rPr sz="1150">
+              <a:rPr sz="1200">
                 <a:latin typeface="Consolas"/>
               </a:rPr>
-              <a:t>    choosing[i] = 0;</a:t>
+              <a:t>            ;                   /* spin on MY node only */</a:t>
             </a:r>
           </a:p>
           <a:p>
@@ -8534,118 +8736,7 @@
               </a:spcAft>
             </a:pPr>
             <a:r>
-              <a:rPr sz="1150">
-                <a:latin typeface="Consolas"/>
-              </a:rPr>
-              <a:t>    FENCE();</a:t>
-            </a:r>
-          </a:p>
-          <a:p>
-            <a:pPr>
-              <a:spcAft>
-                <a:spcPts val="0"/>
-              </a:spcAft>
-            </a:pPr>
-          </a:p>
-          <a:p>
-            <a:pPr>
-              <a:spcAft>
-                <a:spcPts val="0"/>
-              </a:spcAft>
-            </a:pPr>
-            <a:r>
-              <a:rPr sz="1150">
-                <a:latin typeface="Consolas"/>
-              </a:rPr>
-              <a:t>    for (int j = 0; j &lt; n; j++) {</a:t>
-            </a:r>
-          </a:p>
-          <a:p>
-            <a:pPr>
-              <a:spcAft>
-                <a:spcPts val="0"/>
-              </a:spcAft>
-            </a:pPr>
-            <a:r>
-              <a:rPr sz="1150">
-                <a:latin typeface="Consolas"/>
-              </a:rPr>
-              <a:t>        while (choosing[j])</a:t>
-            </a:r>
-          </a:p>
-          <a:p>
-            <a:pPr>
-              <a:spcAft>
-                <a:spcPts val="0"/>
-              </a:spcAft>
-            </a:pPr>
-            <a:r>
-              <a:rPr sz="1150">
-                <a:latin typeface="Consolas"/>
-              </a:rPr>
-              <a:t>            ;                   /* j is still picking */</a:t>
-            </a:r>
-          </a:p>
-          <a:p>
-            <a:pPr>
-              <a:spcAft>
-                <a:spcPts val="0"/>
-              </a:spcAft>
-            </a:pPr>
-            <a:r>
-              <a:rPr sz="1150">
-                <a:latin typeface="Consolas"/>
-              </a:rPr>
-              <a:t>        while (number[j] != 0 &amp;&amp;</a:t>
-            </a:r>
-          </a:p>
-          <a:p>
-            <a:pPr>
-              <a:spcAft>
-                <a:spcPts val="0"/>
-              </a:spcAft>
-            </a:pPr>
-            <a:r>
-              <a:rPr sz="1150">
-                <a:latin typeface="Consolas"/>
-              </a:rPr>
-              <a:t>               (number[j] &lt; number[i] ||</a:t>
-            </a:r>
-          </a:p>
-          <a:p>
-            <a:pPr>
-              <a:spcAft>
-                <a:spcPts val="0"/>
-              </a:spcAft>
-            </a:pPr>
-            <a:r>
-              <a:rPr sz="1150">
-                <a:latin typeface="Consolas"/>
-              </a:rPr>
-              <a:t>                (number[j] == number[i] &amp;&amp; j &lt; i)))</a:t>
-            </a:r>
-          </a:p>
-          <a:p>
-            <a:pPr>
-              <a:spcAft>
-                <a:spcPts val="0"/>
-              </a:spcAft>
-            </a:pPr>
-            <a:r>
-              <a:rPr sz="1150">
-                <a:latin typeface="Consolas"/>
-              </a:rPr>
-              <a:t>            ;                   /* j is ahead of me */</a:t>
-            </a:r>
-          </a:p>
-          <a:p>
-            <a:pPr>
-              <a:spcAft>
-                <a:spcPts val="0"/>
-              </a:spcAft>
-            </a:pPr>
-            <a:r>
-              <a:rPr sz="1150">
+              <a:rPr sz="1200">
                 <a:latin typeface="Consolas"/>
               </a:rPr>
               <a:t>    }</a:t>
@@ -8658,79 +8749,7 @@
               </a:spcAft>
             </a:pPr>
             <a:r>
-              <a:rPr sz="1150">
-                <a:latin typeface="Consolas"/>
-              </a:rPr>
-              <a:t>}</a:t>
-            </a:r>
-          </a:p>
-          <a:p>
-            <a:pPr>
-              <a:spcAft>
-                <a:spcPts val="0"/>
-              </a:spcAft>
-            </a:pPr>
-          </a:p>
-          <a:p>
-            <a:pPr>
-              <a:spcAft>
-                <a:spcPts val="0"/>
-              </a:spcAft>
-            </a:pPr>
-            <a:r>
-              <a:rPr sz="1150">
-                <a:latin typeface="Consolas"/>
-              </a:rPr>
-              <a:t>void lock_release(int i)</a:t>
-            </a:r>
-          </a:p>
-          <a:p>
-            <a:pPr>
-              <a:spcAft>
-                <a:spcPts val="0"/>
-              </a:spcAft>
-            </a:pPr>
-            <a:r>
-              <a:rPr sz="1150">
-                <a:latin typeface="Consolas"/>
-              </a:rPr>
-              <a:t>{</a:t>
-            </a:r>
-          </a:p>
-          <a:p>
-            <a:pPr>
-              <a:spcAft>
-                <a:spcPts val="0"/>
-              </a:spcAft>
-            </a:pPr>
-            <a:r>
-              <a:rPr sz="1150">
-                <a:latin typeface="Consolas"/>
-              </a:rPr>
-              <a:t>    FENCE();</a:t>
-            </a:r>
-          </a:p>
-          <a:p>
-            <a:pPr>
-              <a:spcAft>
-                <a:spcPts val="0"/>
-              </a:spcAft>
-            </a:pPr>
-            <a:r>
-              <a:rPr sz="1150">
-                <a:latin typeface="Consolas"/>
-              </a:rPr>
-              <a:t>    number[i] = 0;</a:t>
-            </a:r>
-          </a:p>
-          <a:p>
-            <a:pPr>
-              <a:spcAft>
-                <a:spcPts val="0"/>
-              </a:spcAft>
-            </a:pPr>
-            <a:r>
-              <a:rPr sz="1150">
+              <a:rPr sz="1200">
                 <a:latin typeface="Consolas"/>
               </a:rPr>
               <a:t>}</a:t>
@@ -8772,7 +8791,7 @@
           <a:lstStyle/>
           <a:p>
             <a:r>
-              <a:t>Bakery: Mutual Exclusion and Deadlock</a:t>
+              <a:t>MCS: Mutual Exclusion and Deadlock</a:t>
             </a:r>
           </a:p>
         </p:txBody>
@@ -8819,8 +8838,8 @@
         </p:nvSpPr>
         <p:spPr>
           <a:xfrm>
-            <a:off x="822960" y="1554480"/>
-            <a:ext cx="10789920" cy="4937760"/>
+            <a:off x="548640" y="1554480"/>
+            <a:ext cx="4389120" cy="4937760"/>
           </a:xfrm>
           <a:prstGeom prst="rect">
             <a:avLst/>
@@ -8839,8 +8858,8 @@
               </a:spcAft>
             </a:pPr>
             <a:r>
-              <a:rPr sz="2000"/>
-              <a:t>• Mutual exclusion: (number, id) pairs are unique and ordered; a thread enters only after every thread with a smaller pair has left</a:t>
+              <a:rPr sz="1700"/>
+              <a:t>• Mutual exclusion: the exchange gives every thread one place in one queue; only the head is inside, and it wakes exactly one node</a:t>
             </a:r>
           </a:p>
           <a:p>
@@ -8850,8 +8869,8 @@
               </a:spcAft>
             </a:pPr>
             <a:r>
-              <a:rPr sz="2000"/>
-              <a:t>• choosing[] closes the race where j has read the maximum but not yet written its number</a:t>
+              <a:rPr sz="1700"/>
+              <a:t>• No deadlock: the holder always hands over — to the next node, or resets tail when nobody waits</a:t>
             </a:r>
           </a:p>
           <a:p>
@@ -8861,8 +8880,8 @@
               </a:spcAft>
             </a:pPr>
             <a:r>
-              <a:rPr sz="2000"/>
-              <a:t>• No deadlock: the waiting thread with the smallest pair waits for nobody, so it enters</a:t>
+              <a:rPr sz="1700"/>
+              <a:t>• release() waits for a waiter that has swapped tail but not linked in yet</a:t>
             </a:r>
           </a:p>
           <a:p>
@@ -8872,19 +8891,215 @@
               </a:spcAft>
             </a:pPr>
             <a:r>
-              <a:rPr sz="2000"/>
-              <a:t>• Like Peterson, it needs memory fences on x86 (FENCE() in the code)</a:t>
-            </a:r>
-          </a:p>
-          <a:p>
-            <a:pPr>
-              <a:spcAft>
-                <a:spcPts val="800"/>
-              </a:spcAft>
-            </a:pPr>
-            <a:r>
-              <a:rPr sz="2000"/>
+              <a:rPr sz="1700"/>
               <a:t>• Measured: all 24 runs (1–8 threads, all CPUs and one CPU) finished with lost = 0</a:t>
+            </a:r>
+          </a:p>
+        </p:txBody>
+      </p:sp>
+      <p:sp>
+        <p:nvSpPr>
+          <p:cNvPr id="5" name="TextBox 4"/>
+          <p:cNvSpPr txBox="1"/>
+          <p:nvPr/>
+        </p:nvSpPr>
+        <p:spPr>
+          <a:xfrm>
+            <a:off x="5120640" y="1463040"/>
+            <a:ext cx="6675120" cy="2636520"/>
+          </a:xfrm>
+          <a:prstGeom prst="rect">
+            <a:avLst/>
+          </a:prstGeom>
+          <a:solidFill>
+            <a:srgbClr val="F4F4F4"/>
+          </a:solidFill>
+        </p:spPr>
+        <p:txBody>
+          <a:bodyPr wrap="none">
+            <a:spAutoFit/>
+          </a:bodyPr>
+          <a:lstStyle/>
+          <a:p>
+            <a:pPr>
+              <a:spcAft>
+                <a:spcPts val="0"/>
+              </a:spcAft>
+            </a:pPr>
+            <a:r>
+              <a:rPr sz="1150">
+                <a:latin typeface="Consolas"/>
+              </a:rPr>
+              <a:t>void lock_release(int id)</a:t>
+            </a:r>
+          </a:p>
+          <a:p>
+            <a:pPr>
+              <a:spcAft>
+                <a:spcPts val="0"/>
+              </a:spcAft>
+            </a:pPr>
+            <a:r>
+              <a:rPr sz="1150">
+                <a:latin typeface="Consolas"/>
+              </a:rPr>
+              <a:t>{</a:t>
+            </a:r>
+          </a:p>
+          <a:p>
+            <a:pPr>
+              <a:spcAft>
+                <a:spcPts val="0"/>
+              </a:spcAft>
+            </a:pPr>
+            <a:r>
+              <a:rPr sz="1150">
+                <a:latin typeface="Consolas"/>
+              </a:rPr>
+              <a:t>    struct node *me = &amp;qnode[id];</a:t>
+            </a:r>
+          </a:p>
+          <a:p>
+            <a:pPr>
+              <a:spcAft>
+                <a:spcPts val="0"/>
+              </a:spcAft>
+            </a:pPr>
+            <a:r>
+              <a:rPr sz="1150">
+                <a:latin typeface="Consolas"/>
+              </a:rPr>
+              <a:t>    struct node *next = LOAD(&amp;me-&gt;next);</a:t>
+            </a:r>
+          </a:p>
+          <a:p>
+            <a:pPr>
+              <a:spcAft>
+                <a:spcPts val="0"/>
+              </a:spcAft>
+            </a:pPr>
+            <a:r>
+              <a:rPr sz="1150">
+                <a:latin typeface="Consolas"/>
+              </a:rPr>
+              <a:t>    if (next == NULL) {</a:t>
+            </a:r>
+          </a:p>
+          <a:p>
+            <a:pPr>
+              <a:spcAft>
+                <a:spcPts val="0"/>
+              </a:spcAft>
+            </a:pPr>
+            <a:r>
+              <a:rPr sz="1150">
+                <a:latin typeface="Consolas"/>
+              </a:rPr>
+              <a:t>        struct node *expect = me;</a:t>
+            </a:r>
+          </a:p>
+          <a:p>
+            <a:pPr>
+              <a:spcAft>
+                <a:spcPts val="0"/>
+              </a:spcAft>
+            </a:pPr>
+            <a:r>
+              <a:rPr sz="1150">
+                <a:latin typeface="Consolas"/>
+              </a:rPr>
+              <a:t>        if (__atomic_compare_exchange_n(&amp;tail, &amp;expect, NULL, 0,</a:t>
+            </a:r>
+          </a:p>
+          <a:p>
+            <a:pPr>
+              <a:spcAft>
+                <a:spcPts val="0"/>
+              </a:spcAft>
+            </a:pPr>
+            <a:r>
+              <a:rPr sz="1150">
+                <a:latin typeface="Consolas"/>
+              </a:rPr>
+              <a:t>                                        __ATOMIC_RELEASE, __ATOMIC_RELAXED))</a:t>
+            </a:r>
+          </a:p>
+          <a:p>
+            <a:pPr>
+              <a:spcAft>
+                <a:spcPts val="0"/>
+              </a:spcAft>
+            </a:pPr>
+            <a:r>
+              <a:rPr sz="1150">
+                <a:latin typeface="Consolas"/>
+              </a:rPr>
+              <a:t>            return;             /* nobody waiting: lock is free */</a:t>
+            </a:r>
+          </a:p>
+          <a:p>
+            <a:pPr>
+              <a:spcAft>
+                <a:spcPts val="0"/>
+              </a:spcAft>
+            </a:pPr>
+            <a:r>
+              <a:rPr sz="1150">
+                <a:latin typeface="Consolas"/>
+              </a:rPr>
+              <a:t>        while ((next = LOAD(&amp;me-&gt;next)) == NULL)</a:t>
+            </a:r>
+          </a:p>
+          <a:p>
+            <a:pPr>
+              <a:spcAft>
+                <a:spcPts val="0"/>
+              </a:spcAft>
+            </a:pPr>
+            <a:r>
+              <a:rPr sz="1150">
+                <a:latin typeface="Consolas"/>
+              </a:rPr>
+              <a:t>            ;                   /* a waiter is still linking in */</a:t>
+            </a:r>
+          </a:p>
+          <a:p>
+            <a:pPr>
+              <a:spcAft>
+                <a:spcPts val="0"/>
+              </a:spcAft>
+            </a:pPr>
+            <a:r>
+              <a:rPr sz="1150">
+                <a:latin typeface="Consolas"/>
+              </a:rPr>
+              <a:t>    }</a:t>
+            </a:r>
+          </a:p>
+          <a:p>
+            <a:pPr>
+              <a:spcAft>
+                <a:spcPts val="0"/>
+              </a:spcAft>
+            </a:pPr>
+            <a:r>
+              <a:rPr sz="1150">
+                <a:latin typeface="Consolas"/>
+              </a:rPr>
+              <a:t>    STORE(&amp;next-&gt;locked, 0);    /* hand the lock to the next thread */</a:t>
+            </a:r>
+          </a:p>
+          <a:p>
+            <a:pPr>
+              <a:spcAft>
+                <a:spcPts val="0"/>
+              </a:spcAft>
+            </a:pPr>
+            <a:r>
+              <a:rPr sz="1150">
+                <a:latin typeface="Consolas"/>
+              </a:rPr>
+              <a:t>}</a:t>
             </a:r>
           </a:p>
         </p:txBody>
@@ -8923,7 +9138,7 @@
           <a:lstStyle/>
           <a:p>
             <a:r>
-              <a:t>Bakery: Performance</a:t>
+              <a:t>MCS: Performance</a:t>
             </a:r>
           </a:p>
         </p:txBody>
@@ -9008,8 +9223,8 @@
               </a:spcAft>
             </a:pPr>
             <a:r>
-              <a:rPr sz="1900"/>
-              <a:t>• lock() scans all N threads twice: O(N) per acquisition</a:t>
+              <a:rPr sz="1800"/>
+              <a:t>• Each waiter spins on its own cache line; a handover touches one line</a:t>
             </a:r>
           </a:p>
           <a:p>
@@ -9019,8 +9234,8 @@
               </a:spcAft>
             </a:pPr>
             <a:r>
-              <a:rPr sz="1900"/>
-              <a:t>• All CPUs: 8.4 M → 4.8 M → 3.0 M acq/s at 2/4/8 threads</a:t>
+              <a:rPr sz="1800"/>
+              <a:t>• All CPUs, 8 threads: 6.9 M acq/s (TAS: 5.7 M)</a:t>
             </a:r>
           </a:p>
           <a:p>
@@ -9030,12 +9245,23 @@
               </a:spcAft>
             </a:pPr>
             <a:r>
-              <a:rPr sz="1900">
+              <a:rPr sz="1800">
                 <a:solidFill>
                   <a:srgbClr val="C0392B"/>
                 </a:solidFill>
               </a:rPr>
-              <a:t>• One CPU, 8 threads: 90 k acq/s — the next in line must be scheduled first</a:t>
+              <a:t>• One CPU, 8 threads: 511 k acq/s — the next in the queue is not running</a:t>
+            </a:r>
+          </a:p>
+          <a:p>
+            <a:pPr>
+              <a:spcAft>
+                <a:spcPts val="800"/>
+              </a:spcAft>
+            </a:pPr>
+            <a:r>
+              <a:rPr sz="1800"/>
+              <a:t>• In the kernel, spinlocks run with preemption disabled, so a queued waiter is never descheduled</a:t>
             </a:r>
           </a:p>
         </p:txBody>
@@ -9074,7 +9300,7 @@
           <a:lstStyle/>
           <a:p>
             <a:r>
-              <a:t>Bakery: Fairness and Limitations</a:t>
+              <a:t>MCS: Fairness and Limitations</a:t>
             </a:r>
           </a:p>
         </p:txBody>
@@ -9142,7 +9368,7 @@
             </a:pPr>
             <a:r>
               <a:rPr sz="2000"/>
-              <a:t>• First-come, first-served: fairness 1.00 / 0.93 / 0.97 at 2/4/8 threads (all CPUs) — the fairest lock at 8 threads</a:t>
+              <a:t>• First-come, first-served through the queue: fairness 1.00 / 1.00 / 1.00 at 2/4/8 threads (all CPUs) — the fairest lock at 8 threads</a:t>
             </a:r>
           </a:p>
           <a:p>
@@ -9164,7 +9390,7 @@
             </a:pPr>
             <a:r>
               <a:rPr sz="1800"/>
-              <a:t>– O(N) time and O(N) memory per lock</a:t>
+              <a:t>– Needs an atomic exchange (and CAS for release) from the hardware</a:t>
             </a:r>
           </a:p>
           <a:p>
@@ -9175,7 +9401,7 @@
             </a:pPr>
             <a:r>
               <a:rPr sz="1800"/>
-              <a:t>– Numbers grow without bound while threads keep contending (overflow)</a:t>
+              <a:t>– One queue node per waiting thread, passed in or kept per thread</a:t>
             </a:r>
           </a:p>
           <a:p>
@@ -9186,7 +9412,7 @@
             </a:pPr>
             <a:r>
               <a:rPr sz="1800"/>
-              <a:t>– Needs memory fences on modern CPUs; spins instead of sleeping</a:t>
+              <a:t>– A preempted waiter stalls everyone behind it — the kernel disables preemption</a:t>
             </a:r>
           </a:p>
           <a:p>
@@ -9197,7 +9423,7 @@
             </a:pPr>
             <a:r>
               <a:rPr sz="1800"/>
-              <a:t>– Collapses on one CPU: 90 k acq/s at 8 threads</a:t>
+              <a:t>– On one CPU here: 511 k acq/s at 8 threads, fairness 0.00</a:t>
             </a:r>
           </a:p>
         </p:txBody>
@@ -9340,6 +9566,21 @@
               <a:t>How We Evaluate</a:t>
             </a:r>
           </a:p>
+          <a:p>
+            <a:pPr algn="ctr">
+              <a:spcAft>
+                <a:spcPts val="0"/>
+              </a:spcAft>
+            </a:pPr>
+            <a:r>
+              <a:rPr sz="2000">
+                <a:solidFill>
+                  <a:srgbClr val="C0392B"/>
+                </a:solidFill>
+              </a:rPr>
+              <a:t>MCS Lock</a:t>
+            </a:r>
+          </a:p>
         </p:txBody>
       </p:sp>
       <p:sp>
@@ -9538,7 +9779,7 @@
                   <a:srgbClr val="C0392B"/>
                 </a:solidFill>
               </a:rPr>
-              <a:t>Lamport's Bakery Algorithm</a:t>
+              <a:t>Comparison: Throughput</a:t>
             </a:r>
           </a:p>
         </p:txBody>
@@ -9605,7 +9846,7 @@
                   <a:srgbClr val="C0392B"/>
                 </a:solidFill>
               </a:rPr>
-              <a:t>Comparison</a:t>
+              <a:t>Comparison: Summary</a:t>
             </a:r>
           </a:p>
         </p:txBody>
@@ -9711,7 +9952,7 @@
           <a:lstStyle/>
           <a:p>
             <a:r>
-              <a:t>Comparison</a:t>
+              <a:t>Comparison: Throughput</a:t>
             </a:r>
           </a:p>
         </p:txBody>
@@ -9732,12 +9973,12 @@
           <a:lstStyle/>
           <a:p>
             <a:r>
-              <a:t>67070501059</a:t>
-            </a:r>
-          </a:p>
-          <a:p>
-            <a:r>
-              <a:t>Chanon Lhumsa-ard</a:t>
+              <a:t>67070501040</a:t>
+            </a:r>
+          </a:p>
+          <a:p>
+            <a:r>
+              <a:t>Worawut Sereethai</a:t>
             </a:r>
           </a:p>
         </p:txBody>
@@ -9919,14 +10160,40 @@
           <a:lstStyle/>
           <a:p>
             <a:r>
-              <a:t>Summary</a:t>
-            </a:r>
-          </a:p>
-        </p:txBody>
-      </p:sp>
-      <p:sp>
-        <p:nvSpPr>
-          <p:cNvPr id="3" name="TextBox 2"/>
+              <a:t>Comparison: Summary</a:t>
+            </a:r>
+          </a:p>
+        </p:txBody>
+      </p:sp>
+      <p:sp>
+        <p:nvSpPr>
+          <p:cNvPr id="3" name="Text Placeholder 2"/>
+          <p:cNvSpPr>
+            <a:spLocks noGrp="1"/>
+          </p:cNvSpPr>
+          <p:nvPr>
+            <p:ph type="body" idx="1"/>
+          </p:nvPr>
+        </p:nvSpPr>
+        <p:spPr/>
+        <p:txBody>
+          <a:bodyPr/>
+          <a:lstStyle/>
+          <a:p>
+            <a:r>
+              <a:t>67070501059</a:t>
+            </a:r>
+          </a:p>
+          <a:p>
+            <a:r>
+              <a:t>Chanon Lhumsa-ard</a:t>
+            </a:r>
+          </a:p>
+        </p:txBody>
+      </p:sp>
+      <p:sp>
+        <p:nvSpPr>
+          <p:cNvPr id="4" name="TextBox 3"/>
           <p:cNvSpPr txBox="1"/>
           <p:nvPr/>
         </p:nvSpPr>
@@ -9958,6 +10225,79 @@
           </a:p>
         </p:txBody>
       </p:sp>
+    </p:spTree>
+  </p:cSld>
+  <p:clrMapOvr>
+    <a:masterClrMapping/>
+  </p:clrMapOvr>
+</p:sld>
+</file>
+
+<file path=ppt/slides/slide23.xml><?xml version="1.0" encoding="utf-8"?>
+<p:sld xmlns:a="http://schemas.openxmlformats.org/drawingml/2006/main" xmlns:p="http://schemas.openxmlformats.org/presentationml/2006/main" xmlns:r="http://schemas.openxmlformats.org/officeDocument/2006/relationships">
+  <p:cSld>
+    <p:spTree>
+      <p:nvGrpSpPr>
+        <p:cNvPr id="1" name=""/>
+        <p:cNvGrpSpPr/>
+        <p:nvPr/>
+      </p:nvGrpSpPr>
+      <p:grpSpPr/>
+      <p:sp>
+        <p:nvSpPr>
+          <p:cNvPr id="2" name="Title 1"/>
+          <p:cNvSpPr>
+            <a:spLocks noGrp="1"/>
+          </p:cNvSpPr>
+          <p:nvPr>
+            <p:ph type="title"/>
+          </p:nvPr>
+        </p:nvSpPr>
+        <p:spPr/>
+        <p:txBody>
+          <a:bodyPr/>
+          <a:lstStyle/>
+          <a:p>
+            <a:r>
+              <a:t>Summary</a:t>
+            </a:r>
+          </a:p>
+        </p:txBody>
+      </p:sp>
+      <p:sp>
+        <p:nvSpPr>
+          <p:cNvPr id="3" name="TextBox 2"/>
+          <p:cNvSpPr txBox="1"/>
+          <p:nvPr/>
+        </p:nvSpPr>
+        <p:spPr>
+          <a:xfrm>
+            <a:off x="11247120" y="6400800"/>
+            <a:ext cx="731520" cy="365760"/>
+          </a:xfrm>
+          <a:prstGeom prst="rect">
+            <a:avLst/>
+          </a:prstGeom>
+          <a:noFill/>
+        </p:spPr>
+        <p:txBody>
+          <a:bodyPr wrap="none">
+            <a:spAutoFit/>
+          </a:bodyPr>
+          <a:lstStyle/>
+          <a:p>
+            <a:pPr algn="r"/>
+            <a:r>
+              <a:rPr sz="1200">
+                <a:solidFill>
+                  <a:srgbClr val="808080"/>
+                </a:solidFill>
+              </a:rPr>
+              <a:t>23</a:t>
+            </a:r>
+          </a:p>
+        </p:txBody>
+      </p:sp>
       <p:graphicFrame>
         <p:nvGraphicFramePr>
           <p:cNvPr id="4" name="Table 3"/>
@@ -9967,8 +10307,8 @@
           <p:nvPr/>
         </p:nvGraphicFramePr>
         <p:xfrm>
-          <a:off x="457200" y="1554480"/>
-          <a:ext cx="11247120" cy="2743200"/>
+          <a:off x="457200" y="1463040"/>
+          <a:ext cx="11247120" cy="2468880"/>
         </p:xfrm>
         <a:graphic>
           <a:graphicData uri="http://schemas.openxmlformats.org/drawingml/2006/table">
@@ -9985,7 +10325,7 @@
                 <a:gridCol w="1463040"/>
                 <a:gridCol w="1280160"/>
               </a:tblGrid>
-              <a:tr h="457200">
+              <a:tr h="411480">
                 <a:tc>
                   <a:txBody>
                     <a:bodyPr/>
@@ -10078,7 +10418,7 @@
                   <a:tcPr/>
                 </a:tc>
               </a:tr>
-              <a:tr h="457200">
+              <a:tr h="411480">
                 <a:tc>
                   <a:txBody>
                     <a:bodyPr/>
@@ -10151,7 +10491,7 @@
                     <a:p>
                       <a:r>
                         <a:rPr sz="1400"/>
-                        <a:t>18 M</a:t>
+                        <a:t>15 M</a:t>
                       </a:r>
                     </a:p>
                   </a:txBody>
@@ -10164,14 +10504,14 @@
                     <a:p>
                       <a:r>
                         <a:rPr sz="1400"/>
-                        <a:t>192 k</a:t>
+                        <a:t>165 k</a:t>
                       </a:r>
                     </a:p>
                   </a:txBody>
                   <a:tcPr/>
                 </a:tc>
               </a:tr>
-              <a:tr h="457200">
+              <a:tr h="411480">
                 <a:tc>
                   <a:txBody>
                     <a:bodyPr/>
@@ -10231,7 +10571,7 @@
                     <a:p>
                       <a:r>
                         <a:rPr sz="1400"/>
-                        <a:t>0.45</a:t>
+                        <a:t>0.75</a:t>
                       </a:r>
                     </a:p>
                   </a:txBody>
@@ -10244,7 +10584,7 @@
                     <a:p>
                       <a:r>
                         <a:rPr sz="1400"/>
-                        <a:t>6.4 M</a:t>
+                        <a:t>6.1 M</a:t>
                       </a:r>
                     </a:p>
                   </a:txBody>
@@ -10264,7 +10604,7 @@
                   <a:tcPr/>
                 </a:tc>
               </a:tr>
-              <a:tr h="457200">
+              <a:tr h="411480">
                 <a:tc>
                   <a:txBody>
                     <a:bodyPr/>
@@ -10272,7 +10612,7 @@
                     <a:p>
                       <a:r>
                         <a:rPr sz="1400"/>
-                        <a:t>Bakery (8 thr)</a:t>
+                        <a:t>MCS (8 thr)</a:t>
                       </a:r>
                     </a:p>
                   </a:txBody>
@@ -10285,7 +10625,7 @@
                     <a:p>
                       <a:r>
                         <a:rPr sz="1400"/>
-                        <a:t>loads/stores + fence</a:t>
+                        <a:t>atomic exchange + CAS</a:t>
                       </a:r>
                     </a:p>
                   </a:txBody>
@@ -10324,7 +10664,7 @@
                     <a:p>
                       <a:r>
                         <a:rPr sz="1400"/>
-                        <a:t>0.97</a:t>
+                        <a:t>1.00</a:t>
                       </a:r>
                     </a:p>
                   </a:txBody>
@@ -10337,7 +10677,7 @@
                     <a:p>
                       <a:r>
                         <a:rPr sz="1400"/>
-                        <a:t>3.0 M</a:t>
+                        <a:t>6.9 M</a:t>
                       </a:r>
                     </a:p>
                   </a:txBody>
@@ -10350,14 +10690,14 @@
                     <a:p>
                       <a:r>
                         <a:rPr sz="1400"/>
-                        <a:t>90 k</a:t>
+                        <a:t>511 k</a:t>
                       </a:r>
                     </a:p>
                   </a:txBody>
                   <a:tcPr/>
                 </a:tc>
               </a:tr>
-              <a:tr h="457200">
+              <a:tr h="411480">
                 <a:tc>
                   <a:txBody>
                     <a:bodyPr/>
@@ -10417,7 +10757,7 @@
                     <a:p>
                       <a:r>
                         <a:rPr sz="1400"/>
-                        <a:t>0.83</a:t>
+                        <a:t>0.82</a:t>
                       </a:r>
                     </a:p>
                   </a:txBody>
@@ -10430,7 +10770,7 @@
                     <a:p>
                       <a:r>
                         <a:rPr sz="1400"/>
-                        <a:t>5.8 M</a:t>
+                        <a:t>5.7 M</a:t>
                       </a:r>
                     </a:p>
                   </a:txBody>
@@ -10450,7 +10790,7 @@
                   <a:tcPr/>
                 </a:tc>
               </a:tr>
-              <a:tr h="457200">
+              <a:tr h="411480">
                 <a:tc>
                   <a:txBody>
                     <a:bodyPr/>
@@ -10510,7 +10850,7 @@
                     <a:p>
                       <a:r>
                         <a:rPr sz="1400"/>
-                        <a:t>0.89</a:t>
+                        <a:t>0.86</a:t>
                       </a:r>
                     </a:p>
                   </a:txBody>
@@ -10536,7 +10876,7 @@
                     <a:p>
                       <a:r>
                         <a:rPr sz="1400"/>
-                        <a:t>56 M</a:t>
+                        <a:t>54 M</a:t>
                       </a:r>
                     </a:p>
                   </a:txBody>
@@ -10555,8 +10895,8 @@
         </p:nvSpPr>
         <p:spPr>
           <a:xfrm>
-            <a:off x="457200" y="4663440"/>
-            <a:ext cx="11247120" cy="1828800"/>
+            <a:off x="457200" y="4297680"/>
+            <a:ext cx="11247120" cy="1371600"/>
           </a:xfrm>
           <a:prstGeom prst="rect">
             <a:avLst/>
@@ -10591,106 +10931,7 @@
                   <a:srgbClr val="C0392B"/>
                 </a:solidFill>
               </a:rPr>
-              <a:t>• Peterson and Bakery give mutual exclusion on x86 only with the fence</a:t>
-            </a:r>
-          </a:p>
-        </p:txBody>
-      </p:sp>
-    </p:spTree>
-  </p:cSld>
-  <p:clrMapOvr>
-    <a:masterClrMapping/>
-  </p:clrMapOvr>
-</p:sld>
-</file>
-
-<file path=ppt/slides/slide23.xml><?xml version="1.0" encoding="utf-8"?>
-<p:sld xmlns:a="http://schemas.openxmlformats.org/drawingml/2006/main" xmlns:p="http://schemas.openxmlformats.org/presentationml/2006/main" xmlns:r="http://schemas.openxmlformats.org/officeDocument/2006/relationships">
-  <p:cSld>
-    <p:spTree>
-      <p:nvGrpSpPr>
-        <p:cNvPr id="1" name=""/>
-        <p:cNvGrpSpPr/>
-        <p:nvPr/>
-      </p:nvGrpSpPr>
-      <p:grpSpPr/>
-      <p:sp>
-        <p:nvSpPr>
-          <p:cNvPr id="2" name="Title 1"/>
-          <p:cNvSpPr>
-            <a:spLocks noGrp="1"/>
-          </p:cNvSpPr>
-          <p:nvPr>
-            <p:ph type="title"/>
-          </p:nvPr>
-        </p:nvSpPr>
-        <p:spPr/>
-        <p:txBody>
-          <a:bodyPr/>
-          <a:lstStyle/>
-          <a:p>
-            <a:r>
-              <a:t>Conclusion</a:t>
-            </a:r>
-          </a:p>
-        </p:txBody>
-      </p:sp>
-      <p:sp>
-        <p:nvSpPr>
-          <p:cNvPr id="3" name="Text Placeholder 2"/>
-          <p:cNvSpPr>
-            <a:spLocks noGrp="1"/>
-          </p:cNvSpPr>
-          <p:nvPr>
-            <p:ph type="body" idx="1"/>
-          </p:nvPr>
-        </p:nvSpPr>
-        <p:spPr/>
-        <p:txBody>
-          <a:bodyPr/>
-          <a:lstStyle/>
-          <a:p>
-            <a:r>
-              <a:t>67070501075</a:t>
-            </a:r>
-          </a:p>
-          <a:p>
-            <a:r>
-              <a:t>Siriwan Yindeephot</a:t>
-            </a:r>
-          </a:p>
-        </p:txBody>
-      </p:sp>
-      <p:sp>
-        <p:nvSpPr>
-          <p:cNvPr id="4" name="TextBox 3"/>
-          <p:cNvSpPr txBox="1"/>
-          <p:nvPr/>
-        </p:nvSpPr>
-        <p:spPr>
-          <a:xfrm>
-            <a:off x="11247120" y="6400800"/>
-            <a:ext cx="731520" cy="365760"/>
-          </a:xfrm>
-          <a:prstGeom prst="rect">
-            <a:avLst/>
-          </a:prstGeom>
-          <a:noFill/>
-        </p:spPr>
-        <p:txBody>
-          <a:bodyPr wrap="none">
-            <a:spAutoFit/>
-          </a:bodyPr>
-          <a:lstStyle/>
-          <a:p>
-            <a:pPr algn="r"/>
-            <a:r>
-              <a:rPr sz="1200">
-                <a:solidFill>
-                  <a:srgbClr val="808080"/>
-                </a:solidFill>
-              </a:rPr>
-              <a:t>23</a:t>
+              <a:t>• Peterson gives mutual exclusion on x86 only with the fence</a:t>
             </a:r>
           </a:p>
         </p:txBody>
@@ -10736,7 +10977,33 @@
       </p:sp>
       <p:sp>
         <p:nvSpPr>
-          <p:cNvPr id="3" name="TextBox 2"/>
+          <p:cNvPr id="3" name="Text Placeholder 2"/>
+          <p:cNvSpPr>
+            <a:spLocks noGrp="1"/>
+          </p:cNvSpPr>
+          <p:nvPr>
+            <p:ph type="body" idx="1"/>
+          </p:nvPr>
+        </p:nvSpPr>
+        <p:spPr/>
+        <p:txBody>
+          <a:bodyPr/>
+          <a:lstStyle/>
+          <a:p>
+            <a:r>
+              <a:t>67070501075</a:t>
+            </a:r>
+          </a:p>
+          <a:p>
+            <a:r>
+              <a:t>Siriwan Yindeephot</a:t>
+            </a:r>
+          </a:p>
+        </p:txBody>
+      </p:sp>
+      <p:sp>
+        <p:nvSpPr>
+          <p:cNvPr id="4" name="TextBox 3"/>
           <p:cNvSpPr txBox="1"/>
           <p:nvPr/>
         </p:nvSpPr>
@@ -10764,73 +11031,6 @@
                 </a:solidFill>
               </a:rPr>
               <a:t>24</a:t>
-            </a:r>
-          </a:p>
-        </p:txBody>
-      </p:sp>
-      <p:sp>
-        <p:nvSpPr>
-          <p:cNvPr id="4" name="TextBox 3"/>
-          <p:cNvSpPr txBox="1"/>
-          <p:nvPr/>
-        </p:nvSpPr>
-        <p:spPr>
-          <a:xfrm>
-            <a:off x="822960" y="1554480"/>
-            <a:ext cx="10789920" cy="4937760"/>
-          </a:xfrm>
-          <a:prstGeom prst="rect">
-            <a:avLst/>
-          </a:prstGeom>
-          <a:noFill/>
-        </p:spPr>
-        <p:txBody>
-          <a:bodyPr wrap="square">
-            <a:spAutoFit/>
-          </a:bodyPr>
-          <a:lstStyle/>
-          <a:p>
-            <a:pPr>
-              <a:spcAft>
-                <a:spcPts val="800"/>
-              </a:spcAft>
-            </a:pPr>
-            <a:r>
-              <a:rPr sz="2100"/>
-              <a:t>• All three give mutual exclusion and no deadlock — Peterson and Bakery only with fences on modern CPUs</a:t>
-            </a:r>
-          </a:p>
-          <a:p>
-            <a:pPr>
-              <a:spcAft>
-                <a:spcPts val="800"/>
-              </a:spcAft>
-            </a:pPr>
-            <a:r>
-              <a:rPr sz="2100"/>
-              <a:t>• Software locks (Peterson, Bakery): fair (bounded waiting), but slow and limited (2 threads / O(N))</a:t>
-            </a:r>
-          </a:p>
-          <a:p>
-            <a:pPr>
-              <a:spcAft>
-                <a:spcPts val="800"/>
-              </a:spcAft>
-            </a:pPr>
-            <a:r>
-              <a:rPr sz="2100"/>
-              <a:t>• Hardware LL/SC: one short loop, fast, but no fairness and not on x86</a:t>
-            </a:r>
-          </a:p>
-          <a:p>
-            <a:pPr>
-              <a:spcAft>
-                <a:spcPts val="800"/>
-              </a:spcAft>
-            </a:pPr>
-            <a:r>
-              <a:rPr sz="2100"/>
-              <a:t>• Spinning on one CPU wastes time slices; sleeping locks (futex, pthread_mutex) avoid it</a:t>
             </a:r>
           </a:p>
         </p:txBody>
@@ -10869,7 +11069,7 @@
           <a:lstStyle/>
           <a:p>
             <a:r>
-              <a:t>References</a:t>
+              <a:t>Conclusion</a:t>
             </a:r>
           </a:p>
         </p:txBody>
@@ -10936,6 +11136,157 @@
               </a:spcAft>
             </a:pPr>
             <a:r>
+              <a:rPr sz="2000"/>
+              <a:t>• All three give mutual exclusion and no deadlock — Peterson only with a fence on modern CPUs</a:t>
+            </a:r>
+          </a:p>
+          <a:p>
+            <a:pPr>
+              <a:spcAft>
+                <a:spcPts val="800"/>
+              </a:spcAft>
+            </a:pPr>
+            <a:r>
+              <a:rPr sz="2000"/>
+              <a:t>• Peterson: software only and fair (bounded waiting), but two threads only</a:t>
+            </a:r>
+          </a:p>
+          <a:p>
+            <a:pPr>
+              <a:spcAft>
+                <a:spcPts val="800"/>
+              </a:spcAft>
+            </a:pPr>
+            <a:r>
+              <a:rPr sz="2000"/>
+              <a:t>• Hardware LL/SC: one short loop, fast, but no fairness and not on x86</a:t>
+            </a:r>
+          </a:p>
+          <a:p>
+            <a:pPr>
+              <a:spcAft>
+                <a:spcPts val="800"/>
+              </a:spcAft>
+            </a:pPr>
+            <a:r>
+              <a:rPr sz="2000"/>
+              <a:t>• MCS: a queue gives first-come, first-served for any number of threads; Linux builds on it</a:t>
+            </a:r>
+          </a:p>
+          <a:p>
+            <a:pPr>
+              <a:spcAft>
+                <a:spcPts val="800"/>
+              </a:spcAft>
+            </a:pPr>
+            <a:r>
+              <a:rPr sz="2000"/>
+              <a:t>• Spinning on one CPU wastes time slices; sleeping locks (futex, pthread_mutex) avoid it</a:t>
+            </a:r>
+          </a:p>
+        </p:txBody>
+      </p:sp>
+    </p:spTree>
+  </p:cSld>
+  <p:clrMapOvr>
+    <a:masterClrMapping/>
+  </p:clrMapOvr>
+</p:sld>
+</file>
+
+<file path=ppt/slides/slide26.xml><?xml version="1.0" encoding="utf-8"?>
+<p:sld xmlns:a="http://schemas.openxmlformats.org/drawingml/2006/main" xmlns:p="http://schemas.openxmlformats.org/presentationml/2006/main" xmlns:r="http://schemas.openxmlformats.org/officeDocument/2006/relationships">
+  <p:cSld>
+    <p:spTree>
+      <p:nvGrpSpPr>
+        <p:cNvPr id="1" name=""/>
+        <p:cNvGrpSpPr/>
+        <p:nvPr/>
+      </p:nvGrpSpPr>
+      <p:grpSpPr/>
+      <p:sp>
+        <p:nvSpPr>
+          <p:cNvPr id="2" name="Title 1"/>
+          <p:cNvSpPr>
+            <a:spLocks noGrp="1"/>
+          </p:cNvSpPr>
+          <p:nvPr>
+            <p:ph type="title"/>
+          </p:nvPr>
+        </p:nvSpPr>
+        <p:spPr/>
+        <p:txBody>
+          <a:bodyPr/>
+          <a:lstStyle/>
+          <a:p>
+            <a:r>
+              <a:t>References</a:t>
+            </a:r>
+          </a:p>
+        </p:txBody>
+      </p:sp>
+      <p:sp>
+        <p:nvSpPr>
+          <p:cNvPr id="3" name="TextBox 2"/>
+          <p:cNvSpPr txBox="1"/>
+          <p:nvPr/>
+        </p:nvSpPr>
+        <p:spPr>
+          <a:xfrm>
+            <a:off x="11247120" y="6400800"/>
+            <a:ext cx="731520" cy="365760"/>
+          </a:xfrm>
+          <a:prstGeom prst="rect">
+            <a:avLst/>
+          </a:prstGeom>
+          <a:noFill/>
+        </p:spPr>
+        <p:txBody>
+          <a:bodyPr wrap="none">
+            <a:spAutoFit/>
+          </a:bodyPr>
+          <a:lstStyle/>
+          <a:p>
+            <a:pPr algn="r"/>
+            <a:r>
+              <a:rPr sz="1200">
+                <a:solidFill>
+                  <a:srgbClr val="808080"/>
+                </a:solidFill>
+              </a:rPr>
+              <a:t>26</a:t>
+            </a:r>
+          </a:p>
+        </p:txBody>
+      </p:sp>
+      <p:sp>
+        <p:nvSpPr>
+          <p:cNvPr id="4" name="TextBox 3"/>
+          <p:cNvSpPr txBox="1"/>
+          <p:nvPr/>
+        </p:nvSpPr>
+        <p:spPr>
+          <a:xfrm>
+            <a:off x="822960" y="1554480"/>
+            <a:ext cx="10789920" cy="4937760"/>
+          </a:xfrm>
+          <a:prstGeom prst="rect">
+            <a:avLst/>
+          </a:prstGeom>
+          <a:noFill/>
+        </p:spPr>
+        <p:txBody>
+          <a:bodyPr wrap="square">
+            <a:spAutoFit/>
+          </a:bodyPr>
+          <a:lstStyle/>
+          <a:p>
+            <a:pPr>
+              <a:spcAft>
+                <a:spcPts val="800"/>
+              </a:spcAft>
+            </a:pPr>
+            <a:r>
               <a:rPr sz="1800"/>
               <a:t>• R. H. Arpaci-Dusseau, A. C. Arpaci-Dusseau, Operating Systems: Three Easy Pieces, ch. 28 “Locks”</a:t>
             </a:r>
@@ -10970,7 +11321,18 @@
             </a:pPr>
             <a:r>
               <a:rPr sz="1800"/>
-              <a:t>• L. Lamport, “A New Solution of Dijkstra's Concurrent Programming Problem”, CACM 17(8), 1974</a:t>
+              <a:t>• J. M. Mellor-Crummey, M. L. Scott, “Algorithms for Scalable Synchronization on Shared-Memory Multiprocessors”, ACM TOCS 9(1), 1991</a:t>
+            </a:r>
+          </a:p>
+          <a:p>
+            <a:pPr>
+              <a:spcAft>
+                <a:spcPts val="800"/>
+              </a:spcAft>
+            </a:pPr>
+            <a:r>
+              <a:rPr sz="1800"/>
+              <a:t>• Linux kernel source: kernel/locking/qspinlock.c</a:t>
             </a:r>
           </a:p>
           <a:p>
@@ -12138,7 +12500,7 @@
                     <a:p>
                       <a:r>
                         <a:rPr sz="1600"/>
-                        <a:t>163,764 – 916,884</a:t>
+                        <a:t>233,108 – 813,401</a:t>
                       </a:r>
                     </a:p>
                   </a:txBody>
@@ -12411,7 +12773,7 @@
             </a:pPr>
             <a:r>
               <a:rPr sz="1900"/>
-              <a:t>• 1 thread: 68 M acq/s — no contention</a:t>
+              <a:t>• 1 thread: 63 M acq/s — no contention</a:t>
             </a:r>
           </a:p>
           <a:p>
@@ -12422,7 +12784,7 @@
             </a:pPr>
             <a:r>
               <a:rPr sz="1900"/>
-              <a:t>• 2 threads, all CPUs: 18 M acq/s — flag and turn move between cores</a:t>
+              <a:t>• 2 threads, all CPUs: 15 M acq/s — flag and turn move between cores</a:t>
             </a:r>
           </a:p>
           <a:p>
@@ -12437,7 +12799,7 @@
                   <a:srgbClr val="C0392B"/>
                 </a:solidFill>
               </a:rPr>
-              <a:t>• 2 threads, one CPU: 192 k acq/s — the waiter spins until the scheduler switches</a:t>
+              <a:t>• 2 threads, one CPU: 165 k acq/s — the waiter spins until the scheduler switches</a:t>
             </a:r>
           </a:p>
           <a:p>
@@ -12566,7 +12928,7 @@
             </a:pPr>
             <a:r>
               <a:rPr sz="2000"/>
-              <a:t>• One CPU, 2 threads: fairness 0.001 (run 1: 126 vs 192,299) — with spinning, the scheduler decides</a:t>
+              <a:t>• One CPU, 2 threads: fairness 0.001 (run 1: 126 vs 93,264) — with spinning, the scheduler decides</a:t>
             </a:r>
           </a:p>
           <a:p>

</xml_diff>